<commit_message>
Add dedicated equity-curve slide (new slide 10) with Alpaca screenshot; slide 9 keeps stats, close moves to slide 11
</commit_message>
<xml_diff>
--- a/submission/presentation.pptx
+++ b/submission/presentation.pptx
@@ -15,9 +15,10 @@
     <p:sldId id="263" r:id="rId9"/>
     <p:sldId id="264" r:id="rId10"/>
     <p:sldId id="265" r:id="rId11"/>
+    <p:sldId id="266" r:id="rId12"/>
   </p:sldIdLst>
   <p:notesMasterIdLst>
-    <p:notesMasterId r:id="rId12"/>
+    <p:notesMasterId r:id="rId13"/>
   </p:notesMasterIdLst>
   <p:sldSz cx="12192000" cy="6858000"/>
   <p:notesSz cx="6858000" cy="12192000"/>
@@ -623,6 +624,94 @@
             <a:fld id="{F7021451-1387-4CA6-816F-3879F97B5CBC}" type="slidenum">
               <a:rPr lang="en-US"/>
               <a:t>10</a:t>
+            </a:fld>
+            <a:endParaRPr lang="en-US"/>
+          </a:p>
+        </p:txBody>
+      </p:sp>
+    </p:spTree>
+    <p:extLst>
+      <p:ext uri="{BB962C8B-B14F-4D97-AF65-F5344CB8AC3E}">
+        <p14:creationId xmlns:p14="http://schemas.microsoft.com/office/powerpoint/2010/main" val="1024086991"/>
+      </p:ext>
+    </p:extLst>
+  </p:cSld>
+  <p:clrMapOvr>
+    <a:masterClrMapping/>
+  </p:clrMapOvr>
+</p:notes>
+</file>
+
+<file path=ppt/notesSlides/notesSlide11.xml><?xml version="1.0" encoding="utf-8"?>
+<p:notes xmlns:a="http://schemas.openxmlformats.org/drawingml/2006/main" xmlns:r="http://schemas.openxmlformats.org/officeDocument/2006/relationships" xmlns:p="http://schemas.openxmlformats.org/presentationml/2006/main">
+  <p:cSld>
+    <p:spTree>
+      <p:nvGrpSpPr>
+        <p:cNvPr id="1" name=""/>
+        <p:cNvGrpSpPr/>
+        <p:nvPr/>
+      </p:nvGrpSpPr>
+      <p:grpSpPr>
+        <a:xfrm>
+          <a:off x="0" y="0"/>
+          <a:ext cx="0" cy="0"/>
+          <a:chOff x="0" y="0"/>
+          <a:chExt cx="0" cy="0"/>
+        </a:xfrm>
+      </p:grpSpPr>
+      <p:sp>
+        <p:nvSpPr>
+          <p:cNvPr id="2" name="Slide Image Placeholder 1"/>
+          <p:cNvSpPr>
+            <a:spLocks noGrp="1" noRot="1" noChangeAspect="1"/>
+          </p:cNvSpPr>
+          <p:nvPr>
+            <p:ph type="sldImg"/>
+          </p:nvPr>
+        </p:nvSpPr>
+        <p:spPr/>
+      </p:sp>
+      <p:sp>
+        <p:nvSpPr>
+          <p:cNvPr id="3" name="Notes Placeholder 2"/>
+          <p:cNvSpPr>
+            <a:spLocks noGrp="1"/>
+          </p:cNvSpPr>
+          <p:nvPr>
+            <p:ph type="body" idx="1"/>
+          </p:nvPr>
+        </p:nvSpPr>
+        <p:spPr/>
+        <p:txBody>
+          <a:bodyPr/>
+          <a:lstStyle/>
+          <a:p>
+            <a:r>
+              <a:rPr lang="en-US" dirty="0"/>
+              <a:t/>
+            </a:r>
+            <a:endParaRPr lang="en-US" dirty="0"/>
+          </a:p>
+        </p:txBody>
+      </p:sp>
+      <p:sp>
+        <p:nvSpPr>
+          <p:cNvPr id="4" name="Slide Number Placeholder 3"/>
+          <p:cNvSpPr>
+            <a:spLocks noGrp="1"/>
+          </p:cNvSpPr>
+          <p:nvPr>
+            <p:ph type="sldNum" sz="quarter" idx="10"/>
+          </p:nvPr>
+        </p:nvSpPr>
+        <p:spPr/>
+        <p:txBody>
+          <a:bodyPr/>
+          <a:lstStyle/>
+          <a:p>
+            <a:fld id="{F7021451-1387-4CA6-816F-3879F97B5CBC}" type="slidenum">
+              <a:rPr lang="en-US"/>
+              <a:t>11</a:t>
             </a:fld>
             <a:endParaRPr lang="en-US"/>
           </a:p>
@@ -1947,6 +2036,257 @@
         </p:nvSpPr>
         <p:spPr>
           <a:xfrm>
+            <a:off x="822960" y="457200"/>
+            <a:ext cx="10058400" cy="640080"/>
+          </a:xfrm>
+          <a:prstGeom prst="rect">
+            <a:avLst/>
+          </a:prstGeom>
+          <a:noFill/>
+          <a:ln/>
+        </p:spPr>
+        <p:txBody>
+          <a:bodyPr wrap="square" lIns="0" tIns="0" rIns="0" bIns="0" rtlCol="0" anchor="ctr"/>
+          <a:lstStyle/>
+          <a:p>
+            <a:pPr indent="0" marL="0">
+              <a:buNone/>
+            </a:pPr>
+            <a:r>
+              <a:rPr lang="en-US" sz="4000" b="1" dirty="0">
+                <a:solidFill>
+                  <a:srgbClr val="E8EEF6"/>
+                </a:solidFill>
+                <a:latin typeface="Calibri" pitchFamily="34" charset="0"/>
+                <a:ea typeface="Calibri" pitchFamily="34" charset="-122"/>
+                <a:cs typeface="Calibri" pitchFamily="34" charset="-120"/>
+              </a:rPr>
+              <a:t>The week on Alpaca</a:t>
+            </a:r>
+            <a:endParaRPr lang="en-US" sz="4000" dirty="0"/>
+          </a:p>
+        </p:txBody>
+      </p:sp>
+      <p:sp>
+        <p:nvSpPr>
+          <p:cNvPr id="3" name="Text 1"/>
+          <p:cNvSpPr txBox="1"/>
+          <p:nvPr/>
+        </p:nvSpPr>
+        <p:spPr>
+          <a:xfrm>
+            <a:off x="822960" y="1143000"/>
+            <a:ext cx="10515600" cy="411480"/>
+          </a:xfrm>
+          <a:prstGeom prst="rect">
+            <a:avLst/>
+          </a:prstGeom>
+          <a:noFill/>
+          <a:ln/>
+        </p:spPr>
+        <p:txBody>
+          <a:bodyPr wrap="square" lIns="0" tIns="0" rIns="0" bIns="0" rtlCol="0" anchor="ctr"/>
+          <a:lstStyle/>
+          <a:p>
+            <a:pPr indent="0" marL="0">
+              <a:buNone/>
+            </a:pPr>
+            <a:r>
+              <a:rPr lang="en-US" sz="1300" dirty="0">
+                <a:solidFill>
+                  <a:srgbClr val="8FA0B5"/>
+                </a:solidFill>
+                <a:latin typeface="Courier New" pitchFamily="34" charset="0"/>
+                <a:ea typeface="Courier New" pitchFamily="34" charset="-122"/>
+                <a:cs typeface="Courier New" pitchFamily="34" charset="-120"/>
+              </a:rPr>
+              <a:t>Paper account PA327FXF8G6D  ·  $100,000 → $101,823  ·  +1.82% total return</a:t>
+            </a:r>
+            <a:endParaRPr lang="en-US" sz="1300" dirty="0"/>
+          </a:p>
+        </p:txBody>
+      </p:sp>
+      <p:pic>
+        <p:nvPicPr>
+          <p:cNvPr id="4" name="Image 0" descr="submission/equity.png">    </p:cNvPr>
+          <p:cNvPicPr>
+            <a:picLocks noChangeAspect="1"/>
+          </p:cNvPicPr>
+          <p:nvPr/>
+        </p:nvPicPr>
+        <p:blipFill>
+          <a:blip r:embed="rId1"/>
+          <a:stretch>
+            <a:fillRect/>
+          </a:stretch>
+        </p:blipFill>
+        <p:spPr>
+          <a:xfrm>
+            <a:off x="1883664" y="1645920"/>
+            <a:ext cx="8394192" cy="4297680"/>
+          </a:xfrm>
+          <a:prstGeom prst="rect">
+            <a:avLst/>
+          </a:prstGeom>
+        </p:spPr>
+      </p:pic>
+      <p:sp>
+        <p:nvSpPr>
+          <p:cNvPr id="5" name="Text 2"/>
+          <p:cNvSpPr txBox="1"/>
+          <p:nvPr/>
+        </p:nvSpPr>
+        <p:spPr>
+          <a:xfrm>
+            <a:off x="822960" y="5989320"/>
+            <a:ext cx="10515600" cy="365760"/>
+          </a:xfrm>
+          <a:prstGeom prst="rect">
+            <a:avLst/>
+          </a:prstGeom>
+          <a:noFill/>
+          <a:ln/>
+        </p:spPr>
+        <p:txBody>
+          <a:bodyPr wrap="square" lIns="0" tIns="0" rIns="0" bIns="0" rtlCol="0" anchor="ctr"/>
+          <a:lstStyle/>
+          <a:p>
+            <a:pPr algn="ctr" indent="0" marL="0">
+              <a:buNone/>
+            </a:pPr>
+            <a:r>
+              <a:rPr lang="en-US" sz="1200" i="1" dirty="0">
+                <a:solidFill>
+                  <a:srgbClr val="8FA0B5"/>
+                </a:solidFill>
+                <a:latin typeface="Calibri" pitchFamily="34" charset="0"/>
+                <a:ea typeface="Calibri" pitchFamily="34" charset="-122"/>
+                <a:cs typeface="Calibri" pitchFamily="34" charset="-120"/>
+              </a:rPr>
+              <a:t>The green +1.07% is Alpaca's same-day change; +1.82% is the total return since the $100,000 start.</a:t>
+            </a:r>
+            <a:endParaRPr lang="en-US" sz="1200" dirty="0"/>
+          </a:p>
+        </p:txBody>
+      </p:sp>
+      <p:sp>
+        <p:nvSpPr>
+          <p:cNvPr id="6" name="Text 3"/>
+          <p:cNvSpPr txBox="1"/>
+          <p:nvPr/>
+        </p:nvSpPr>
+        <p:spPr>
+          <a:xfrm>
+            <a:off x="457200" y="6446520"/>
+            <a:ext cx="5486400" cy="274320"/>
+          </a:xfrm>
+          <a:prstGeom prst="rect">
+            <a:avLst/>
+          </a:prstGeom>
+          <a:noFill/>
+          <a:ln/>
+        </p:spPr>
+        <p:txBody>
+          <a:bodyPr wrap="square" lIns="0" tIns="0" rIns="0" bIns="0" rtlCol="0" anchor="ctr"/>
+          <a:lstStyle/>
+          <a:p>
+            <a:pPr algn="l" indent="0" marL="0">
+              <a:buNone/>
+            </a:pPr>
+            <a:r>
+              <a:rPr lang="en-US" sz="900" dirty="0">
+                <a:solidFill>
+                  <a:srgbClr val="8FA0B5"/>
+                </a:solidFill>
+                <a:latin typeface="Courier New" pitchFamily="34" charset="0"/>
+                <a:ea typeface="Courier New" pitchFamily="34" charset="-122"/>
+                <a:cs typeface="Courier New" pitchFamily="34" charset="-120"/>
+              </a:rPr>
+              <a:t>Risk Gate · Honest Options AI</a:t>
+            </a:r>
+            <a:endParaRPr lang="en-US" sz="900" dirty="0"/>
+          </a:p>
+        </p:txBody>
+      </p:sp>
+      <p:sp>
+        <p:nvSpPr>
+          <p:cNvPr id="7" name="Text 4"/>
+          <p:cNvSpPr txBox="1"/>
+          <p:nvPr/>
+        </p:nvSpPr>
+        <p:spPr>
+          <a:xfrm>
+            <a:off x="11430000" y="6446520"/>
+            <a:ext cx="365760" cy="274320"/>
+          </a:xfrm>
+          <a:prstGeom prst="rect">
+            <a:avLst/>
+          </a:prstGeom>
+          <a:noFill/>
+          <a:ln/>
+        </p:spPr>
+        <p:txBody>
+          <a:bodyPr wrap="square" lIns="0" tIns="0" rIns="0" bIns="0" rtlCol="0" anchor="ctr"/>
+          <a:lstStyle/>
+          <a:p>
+            <a:pPr algn="r" indent="0" marL="0">
+              <a:buNone/>
+            </a:pPr>
+            <a:r>
+              <a:rPr lang="en-US" sz="900" dirty="0">
+                <a:solidFill>
+                  <a:srgbClr val="8FA0B5"/>
+                </a:solidFill>
+                <a:latin typeface="Courier New" pitchFamily="34" charset="0"/>
+                <a:ea typeface="Courier New" pitchFamily="34" charset="-122"/>
+                <a:cs typeface="Courier New" pitchFamily="34" charset="-120"/>
+              </a:rPr>
+              <a:t>10</a:t>
+            </a:r>
+            <a:endParaRPr lang="en-US" sz="900" dirty="0"/>
+          </a:p>
+        </p:txBody>
+      </p:sp>
+    </p:spTree>
+  </p:cSld>
+  <p:clrMapOvr>
+    <a:masterClrMapping/>
+  </p:clrMapOvr>
+</p:sld>
+</file>
+
+<file path=ppt/slides/slide11.xml><?xml version="1.0" encoding="utf-8"?>
+<p:sld xmlns:a="http://schemas.openxmlformats.org/drawingml/2006/main" xmlns:r="http://schemas.openxmlformats.org/officeDocument/2006/relationships" xmlns:p="http://schemas.openxmlformats.org/presentationml/2006/main">
+  <p:cSld name="Slide 11">
+    <p:bg>
+      <p:bgPr>
+        <a:solidFill>
+          <a:srgbClr val="0B1018"/>
+        </a:solidFill>
+      </p:bgPr>
+    </p:bg>
+    <p:spTree>
+      <p:nvGrpSpPr>
+        <p:cNvPr id="1" name=""/>
+        <p:cNvGrpSpPr/>
+        <p:nvPr/>
+      </p:nvGrpSpPr>
+      <p:grpSpPr>
+        <a:xfrm>
+          <a:off x="0" y="0"/>
+          <a:ext cx="0" cy="0"/>
+          <a:chOff x="0" y="0"/>
+          <a:chExt cx="0" cy="0"/>
+        </a:xfrm>
+      </p:grpSpPr>
+      <p:sp>
+        <p:nvSpPr>
+          <p:cNvPr id="2" name="Text 0"/>
+          <p:cNvSpPr txBox="1"/>
+          <p:nvPr/>
+        </p:nvSpPr>
+        <p:spPr>
+          <a:xfrm>
             <a:off x="822960" y="822960"/>
             <a:ext cx="1828800" cy="1280160"/>
           </a:xfrm>
@@ -6826,7 +7166,7 @@
                 <a:ea typeface="Calibri" pitchFamily="34" charset="-122"/>
                 <a:cs typeface="Calibri" pitchFamily="34" charset="-120"/>
               </a:rPr>
-              <a:t>Final equity $101,823  ·  +1.82% on the week  ·  2 take-profits captured (+54%, +74%)  ·  0 stop-losses</a:t>
+              <a:t>Final equity $101,823  ·  +1.82% total return since the $100k start  ·  2 take-profits (+54% SPY, +74% NVDA)  ·  0 stop-losses  ·  ~1% max drawdown</a:t>
             </a:r>
             <a:endParaRPr lang="en-US" sz="1600" dirty="0"/>
           </a:p>
@@ -6843,7 +7183,7 @@
                 <a:ea typeface="Calibri" pitchFamily="34" charset="-122"/>
                 <a:cs typeface="Calibri" pitchFamily="34" charset="-120"/>
               </a:rPr>
-              <a:t>[ add screenshot: Alpaca equity curve + P&amp;L ]</a:t>
+              <a:t>→  full equity curve on the next slide</a:t>
             </a:r>
             <a:endParaRPr lang="en-US" sz="1600" dirty="0"/>
           </a:p>

</xml_diff>